<commit_message>
Track 1 is a report, not mini-cases
Aman's call. The vendor track now reads as a written report on how this market
sells and deploys, rather than a set of case studies, and what the companies
get in return is a copy of the finished analysis. Changed on the next-phase
slide and on the plan slide so the two agree.

Co-Authored-By: Claude Opus 5 <noreply@anthropic.com>
Claude-Session: https://claude.ai/code/session_01BTrK7PBdfsBnnGwytNEbE8
</commit_message>
<xml_diff>
--- a/manu-data-layer/deck/ip-update-2026-09-28.pptx
+++ b/manu-data-layer/deck/ip-update-2026-09-28.pptx
@@ -9918,7 +9918,7 @@
                 </a:solidFill>
                 <a:latin typeface="Arial"/>
               </a:rPr>
-              <a:t>Written mini-cases on the vendors themselves</a:t>
+              <a:t>A written report on the companies already in this market</a:t>
             </a:r>
           </a:p>
         </p:txBody>
@@ -9932,7 +9932,7 @@
         <p:spPr>
           <a:xfrm>
             <a:off x="742920" y="1717784"/>
-            <a:ext cx="4963080" cy="533400"/>
+            <a:ext cx="4963080" cy="711200"/>
           </a:xfrm>
           <a:prstGeom prst="rect">
             <a:avLst/>
@@ -9957,7 +9957,7 @@
                 </a:solidFill>
                 <a:latin typeface="Arial"/>
               </a:rPr>
-              <a:t>I approach the companies on the map as an HBS student writing short cases on how they sell and deploy, for this independent project. It is a fair trade: they get a careful write-up, I get the economics.</a:t>
+              <a:t>I approach the companies on the map as an HBS student writing a report on how this market sells and deploys, for this independent project. It is a fair trade: they get a copy of the finished analysis, I get the economics.</a:t>
             </a:r>
           </a:p>
         </p:txBody>
@@ -9970,7 +9970,7 @@
         </p:nvSpPr>
         <p:spPr>
           <a:xfrm>
-            <a:off x="782920" y="2401184"/>
+            <a:off x="782920" y="2578984"/>
             <a:ext cx="4923080" cy="171450"/>
           </a:xfrm>
           <a:prstGeom prst="rect">
@@ -10009,7 +10009,7 @@
         </p:nvSpPr>
         <p:spPr>
           <a:xfrm>
-            <a:off x="782920" y="2612634"/>
+            <a:off x="782920" y="2790434"/>
             <a:ext cx="4923080" cy="171450"/>
           </a:xfrm>
           <a:prstGeom prst="rect">
@@ -10048,7 +10048,7 @@
         </p:nvSpPr>
         <p:spPr>
           <a:xfrm>
-            <a:off x="782920" y="2824084"/>
+            <a:off x="782920" y="3001884"/>
             <a:ext cx="4923080" cy="171450"/>
           </a:xfrm>
           <a:prstGeom prst="rect">
@@ -10087,7 +10087,7 @@
         </p:nvSpPr>
         <p:spPr>
           <a:xfrm>
-            <a:off x="782920" y="3035534"/>
+            <a:off x="782920" y="3213334"/>
             <a:ext cx="4923080" cy="171450"/>
           </a:xfrm>
           <a:prstGeom prst="rect">
@@ -10126,7 +10126,7 @@
         </p:nvSpPr>
         <p:spPr>
           <a:xfrm>
-            <a:off x="742920" y="3316984"/>
+            <a:off x="742920" y="3494784"/>
             <a:ext cx="4963080" cy="495300"/>
           </a:xfrm>
           <a:prstGeom prst="rect">
@@ -10881,7 +10881,7 @@
                 </a:solidFill>
                 <a:latin typeface="Arial"/>
               </a:rPr>
-              <a:t>Vendor mini-cases begin</a:t>
+              <a:t>Report research begins</a:t>
             </a:r>
           </a:p>
         </p:txBody>
@@ -10920,7 +10920,7 @@
                 </a:solidFill>
                 <a:latin typeface="Arial"/>
               </a:rPr>
-              <a:t>First four written up; approach letters out to Boston-area plants</a:t>
+              <a:t>First four companies written up; approach letters out to Boston-area plants</a:t>
             </a:r>
           </a:p>
         </p:txBody>

</xml_diff>